<commit_message>
release(oss): 同步主干开源代码更新 [commit: d1bf8a2069374b2663c258e81da0c42e58ce48e7]
</commit_message>
<xml_diff>
--- a/examples/pptx/omniview-tech-presentation.pptx
+++ b/examples/pptx/omniview-tech-presentation.pptx
@@ -8,6 +8,60 @@
     <p:sldId id="258" r:id="rId3"/>
   </p:sldIdLst>
 </p:presentation>
+</file>
+
+<file path=ppt/notesSlides/notesSlide1.xml><?xml version="1.0" encoding="utf-8"?>
+<p:notes xmlns:a="http://schemas.openxmlformats.org/drawingml/2006/main" xmlns:p="http://schemas.openxmlformats.org/presentationml/2006/main">
+  <p:cSld>
+    <p:spTree>
+      <p:sp>
+        <p:txBody>
+          <a:p>
+            <a:r>
+              <a:t>【开场演讲提示】欢迎体验 OmniView 原生 PPTX 矢量幻灯片工作台！本演示文稿由本地纯前端 OOXML 引擎实时解构并渲染，支持 16:9 宽屏自适应、全屏放映与演讲者提词备注。</a:t>
+            </a:r>
+          </a:p>
+        </p:txBody>
+      </p:sp>
+    </p:spTree>
+  </p:cSld>
+</p:notes>
+</file>
+
+<file path=ppt/notesSlides/notesSlide2.xml><?xml version="1.0" encoding="utf-8"?>
+<p:notes xmlns:a="http://schemas.openxmlformats.org/drawingml/2006/main" xmlns:p="http://schemas.openxmlformats.org/presentationml/2006/main">
+  <p:cSld>
+    <p:spTree>
+      <p:sp>
+        <p:txBody>
+          <a:p>
+            <a:r>
+              <a:t>【架构讲解要点】重点向受众介绍零外部网络依赖与本地沙箱安全：解析流水线不通过任何云端中转，完全在本地 WebAssembly 与内存完成解压与矢量绘制，兼顾性能与商业机密安全。</a:t>
+            </a:r>
+          </a:p>
+        </p:txBody>
+      </p:sp>
+    </p:spTree>
+  </p:cSld>
+</p:notes>
+</file>
+
+<file path=ppt/notesSlides/notesSlide3.xml><?xml version="1.0" encoding="utf-8"?>
+<p:notes xmlns:a="http://schemas.openxmlformats.org/drawingml/2006/main" xmlns:p="http://schemas.openxmlformats.org/presentationml/2006/main">
+  <p:cSld>
+    <p:spTree>
+      <p:sp>
+        <p:txBody>
+          <a:p>
+            <a:r>
+              <a:t>【收尾互动建议】引导观众尝试键盘快捷键（←/→/Space 翻页、F5 全屏放映、Home/End 跳转首尾），并展示多页表格与自适应缩略图的联动能力。</a:t>
+            </a:r>
+          </a:p>
+        </p:txBody>
+      </p:sp>
+    </p:spTree>
+  </p:cSld>
+</p:notes>
 </file>
 
 <file path=ppt/slides/slide1.xml><?xml version="1.0" encoding="UTF-8" standalone="yes"?>

</xml_diff>